<commit_message>
Ajusta ticket EQV Ecofitness para R$ 40.174
Com cashback EE de R$ 15.174, o à vista fica em R$ 25.000.

Co-authored-by: sarapizzico-hue <sarapizzico-hue@users.noreply.github.com>
</commit_message>
<xml_diff>
--- a/EQV-Ecofitness-Aldeia.pptx
+++ b/EQV-Ecofitness-Aldeia.pptx
@@ -2491,7 +2491,7 @@
                 <a:ea typeface="Arial" pitchFamily="34" charset="-122"/>
                 <a:cs typeface="Arial" pitchFamily="34" charset="-120"/>
               </a:rPr>
-              <a:t>R$ 30.000</a:t>
+              <a:t>R$ 40.174</a:t>
             </a:r>
             <a:endParaRPr lang="en-US" sz="3000" dirty="0"/>
           </a:p>
@@ -2602,7 +2602,7 @@
                 <a:ea typeface="Arial" pitchFamily="34" charset="-122"/>
                 <a:cs typeface="Arial" pitchFamily="34" charset="-120"/>
               </a:rPr>
-              <a:t>R$ 14.826</a:t>
+              <a:t>R$ 25.000</a:t>
             </a:r>
             <a:endParaRPr lang="en-US" sz="4400" dirty="0"/>
           </a:p>
@@ -2711,7 +2711,7 @@
                 <a:ea typeface="Arial" pitchFamily="34" charset="-122"/>
                 <a:cs typeface="Arial" pitchFamily="34" charset="-120"/>
               </a:rPr>
-              <a:t>12x R$ 1.402</a:t>
+              <a:t>12x R$ 2.363</a:t>
             </a:r>
             <a:endParaRPr lang="en-US" sz="3000" dirty="0"/>
           </a:p>

</xml_diff>